<commit_message>
feat: implement reinforcement learning agent and discrete simulation environment
</commit_message>
<xml_diff>
--- a/Präsentation.pptx
+++ b/Präsentation.pptx
@@ -134,7 +134,7 @@
 <file path=ppt/revisionInfo.xml><?xml version="1.0" encoding="utf-8"?>
 <p1510:revInfo xmlns:a="http://schemas.openxmlformats.org/drawingml/2006/main" xmlns:r="http://schemas.openxmlformats.org/officeDocument/2006/relationships" xmlns:p1510="http://schemas.microsoft.com/office/powerpoint/2015/10/main">
   <p1510:revLst>
-    <p1510:client id="{0F5E977C-521C-4E5D-98F4-08BAD4B2E030}" v="82" dt="2026-09-17T15:13:12.046"/>
+    <p1510:client id="{0F5E977C-521C-4E5D-98F4-08BAD4B2E030}" v="90" dt="2026-09-17T17:36:40.321"/>
   </p1510:revLst>
 </p1510:revInfo>
 </file>
@@ -144,7 +144,7 @@
   <pc:docChgLst>
     <pc:chgData name="Niko Kläsener" userId="b3580cb7-15ad-4c2f-be10-30939a475464" providerId="ADAL" clId="{36612FA6-6914-4267-9ADB-97F4291D668E}"/>
     <pc:docChg chg="undo custSel addSld delSld modSld sldOrd">
-      <pc:chgData name="Niko Kläsener" userId="b3580cb7-15ad-4c2f-be10-30939a475464" providerId="ADAL" clId="{36612FA6-6914-4267-9ADB-97F4291D668E}" dt="2026-09-17T15:13:12.447" v="2042" actId="20577"/>
+      <pc:chgData name="Niko Kläsener" userId="b3580cb7-15ad-4c2f-be10-30939a475464" providerId="ADAL" clId="{36612FA6-6914-4267-9ADB-97F4291D668E}" dt="2026-09-17T17:36:40.310" v="2055" actId="20577"/>
       <pc:docMkLst>
         <pc:docMk/>
       </pc:docMkLst>
@@ -352,7 +352,7 @@
         </pc:cxnChg>
       </pc:sldChg>
       <pc:sldChg chg="addSp delSp modSp new mod">
-        <pc:chgData name="Niko Kläsener" userId="b3580cb7-15ad-4c2f-be10-30939a475464" providerId="ADAL" clId="{36612FA6-6914-4267-9ADB-97F4291D668E}" dt="2026-09-17T15:12:12.991" v="2018" actId="20577"/>
+        <pc:chgData name="Niko Kläsener" userId="b3580cb7-15ad-4c2f-be10-30939a475464" providerId="ADAL" clId="{36612FA6-6914-4267-9ADB-97F4291D668E}" dt="2026-09-17T17:36:40.310" v="2055" actId="20577"/>
         <pc:sldMkLst>
           <pc:docMk/>
           <pc:sldMk cId="2218181734" sldId="261"/>
@@ -374,7 +374,7 @@
           </ac:spMkLst>
         </pc:spChg>
         <pc:graphicFrameChg chg="add mod ord modGraphic">
-          <ac:chgData name="Niko Kläsener" userId="b3580cb7-15ad-4c2f-be10-30939a475464" providerId="ADAL" clId="{36612FA6-6914-4267-9ADB-97F4291D668E}" dt="2026-09-17T13:47:36.243" v="1736" actId="207"/>
+          <ac:chgData name="Niko Kläsener" userId="b3580cb7-15ad-4c2f-be10-30939a475464" providerId="ADAL" clId="{36612FA6-6914-4267-9ADB-97F4291D668E}" dt="2026-09-17T17:36:40.310" v="2055" actId="20577"/>
           <ac:graphicFrameMkLst>
             <pc:docMk/>
             <pc:sldMk cId="2218181734" sldId="261"/>
@@ -917,7 +917,7 @@
         </pc:picChg>
       </pc:sldChg>
       <pc:sldChg chg="addSp delSp modSp add mod ord">
-        <pc:chgData name="Niko Kläsener" userId="b3580cb7-15ad-4c2f-be10-30939a475464" providerId="ADAL" clId="{36612FA6-6914-4267-9ADB-97F4291D668E}" dt="2026-09-17T15:13:03.469" v="2038" actId="20577"/>
+        <pc:chgData name="Niko Kläsener" userId="b3580cb7-15ad-4c2f-be10-30939a475464" providerId="ADAL" clId="{36612FA6-6914-4267-9ADB-97F4291D668E}" dt="2026-09-17T17:34:21.257" v="2043" actId="14826"/>
         <pc:sldMkLst>
           <pc:docMk/>
           <pc:sldMk cId="1339641369" sldId="272"/>
@@ -963,7 +963,7 @@
           </ac:graphicFrameMkLst>
         </pc:graphicFrameChg>
         <pc:picChg chg="mod">
-          <ac:chgData name="Niko Kläsener" userId="b3580cb7-15ad-4c2f-be10-30939a475464" providerId="ADAL" clId="{36612FA6-6914-4267-9ADB-97F4291D668E}" dt="2026-09-16T15:40:59.105" v="1628" actId="14826"/>
+          <ac:chgData name="Niko Kläsener" userId="b3580cb7-15ad-4c2f-be10-30939a475464" providerId="ADAL" clId="{36612FA6-6914-4267-9ADB-97F4291D668E}" dt="2026-09-17T17:34:21.257" v="2043" actId="14826"/>
           <ac:picMkLst>
             <pc:docMk/>
             <pc:sldMk cId="1339641369" sldId="272"/>
@@ -972,7 +972,7 @@
         </pc:picChg>
       </pc:sldChg>
       <pc:sldChg chg="addSp delSp modSp add mod">
-        <pc:chgData name="Niko Kläsener" userId="b3580cb7-15ad-4c2f-be10-30939a475464" providerId="ADAL" clId="{36612FA6-6914-4267-9ADB-97F4291D668E}" dt="2026-09-17T15:13:08.054" v="2040" actId="20577"/>
+        <pc:chgData name="Niko Kläsener" userId="b3580cb7-15ad-4c2f-be10-30939a475464" providerId="ADAL" clId="{36612FA6-6914-4267-9ADB-97F4291D668E}" dt="2026-09-17T17:35:21.574" v="2050" actId="1076"/>
         <pc:sldMkLst>
           <pc:docMk/>
           <pc:sldMk cId="90835972" sldId="273"/>
@@ -1010,7 +1010,7 @@
           </ac:graphicFrameMkLst>
         </pc:graphicFrameChg>
         <pc:picChg chg="add mod">
-          <ac:chgData name="Niko Kläsener" userId="b3580cb7-15ad-4c2f-be10-30939a475464" providerId="ADAL" clId="{36612FA6-6914-4267-9ADB-97F4291D668E}" dt="2026-09-17T14:35:03.861" v="1848" actId="1076"/>
+          <ac:chgData name="Niko Kläsener" userId="b3580cb7-15ad-4c2f-be10-30939a475464" providerId="ADAL" clId="{36612FA6-6914-4267-9ADB-97F4291D668E}" dt="2026-09-17T17:35:21.574" v="2050" actId="1076"/>
           <ac:picMkLst>
             <pc:docMk/>
             <pc:sldMk cId="90835972" sldId="273"/>
@@ -1026,7 +1026,7 @@
           </ac:picMkLst>
         </pc:picChg>
         <pc:picChg chg="add mod">
-          <ac:chgData name="Niko Kläsener" userId="b3580cb7-15ad-4c2f-be10-30939a475464" providerId="ADAL" clId="{36612FA6-6914-4267-9ADB-97F4291D668E}" dt="2026-09-17T14:35:02.298" v="1847" actId="1076"/>
+          <ac:chgData name="Niko Kläsener" userId="b3580cb7-15ad-4c2f-be10-30939a475464" providerId="ADAL" clId="{36612FA6-6914-4267-9ADB-97F4291D668E}" dt="2026-09-17T17:35:09.171" v="2047" actId="14100"/>
           <ac:picMkLst>
             <pc:docMk/>
             <pc:sldMk cId="90835972" sldId="273"/>
@@ -34165,8 +34165,8 @@
         </p:blipFill>
         <p:spPr>
           <a:xfrm>
-            <a:off x="5501628" y="1690688"/>
-            <a:ext cx="5852172" cy="4389129"/>
+            <a:off x="5501628" y="2259649"/>
+            <a:ext cx="5852172" cy="3251206"/>
           </a:xfrm>
           <a:prstGeom prst="rect">
             <a:avLst/>
@@ -34938,8 +34938,8 @@
         </p:blipFill>
         <p:spPr>
           <a:xfrm>
-            <a:off x="5105074" y="2166086"/>
-            <a:ext cx="7086926" cy="3053664"/>
+            <a:off x="4629150" y="1964105"/>
+            <a:ext cx="7290044" cy="2929789"/>
           </a:xfrm>
           <a:prstGeom prst="rect">
             <a:avLst/>
@@ -34968,14 +34968,13 @@
               </a:ext>
             </a:extLst>
           </a:blip>
-          <a:stretch>
-            <a:fillRect/>
-          </a:stretch>
+          <a:srcRect/>
+          <a:stretch/>
         </p:blipFill>
         <p:spPr>
           <a:xfrm>
-            <a:off x="0" y="2166086"/>
-            <a:ext cx="5067300" cy="3053665"/>
+            <a:off x="35197" y="2166087"/>
+            <a:ext cx="4593953" cy="2807416"/>
           </a:xfrm>
           <a:prstGeom prst="rect">
             <a:avLst/>
@@ -37932,7 +37931,7 @@
                 <p:ph idx="1"/>
                 <p:extLst>
                   <p:ext uri="{D42A27DB-BD31-4B8C-83A1-F6EECF244321}">
-                    <p14:modId xmlns:p14="http://schemas.microsoft.com/office/powerpoint/2010/main" val="1203504456"/>
+                    <p14:modId xmlns:p14="http://schemas.microsoft.com/office/powerpoint/2010/main" val="2995992197"/>
                   </p:ext>
                 </p:extLst>
               </p:nvPr>
@@ -38887,7 +38886,17 @@
                                 </m:sSup>
                                 <m:r>
                                   <a:rPr lang="de-DE" b="0" smtClean="0"/>
-                                  <m:t>=1000</m:t>
+                                  <m:t>=</m:t>
+                                </m:r>
+                                <m:r>
+                                  <a:rPr lang="de-DE" b="0" i="0" smtClean="0">
+                                    <a:latin typeface="Cambria Math" panose="02040503050406030204" pitchFamily="18" charset="0"/>
+                                  </a:rPr>
+                                  <m:t>2</m:t>
+                                </m:r>
+                                <m:r>
+                                  <a:rPr lang="de-DE" b="0" smtClean="0"/>
+                                  <m:t>000</m:t>
                                 </m:r>
                               </m:oMath>
                             </m:oMathPara>
@@ -39037,7 +39046,13 @@
                                 </m:sSub>
                                 <m:r>
                                   <a:rPr lang="de-DE" b="0" smtClean="0"/>
-                                  <m:t>=3</m:t>
+                                  <m:t>=</m:t>
+                                </m:r>
+                                <m:r>
+                                  <a:rPr lang="de-DE" b="0" i="0" smtClean="0">
+                                    <a:latin typeface="Cambria Math" panose="02040503050406030204" pitchFamily="18" charset="0"/>
+                                  </a:rPr>
+                                  <m:t>10</m:t>
                                 </m:r>
                               </m:oMath>
                             </m:oMathPara>
@@ -39075,7 +39090,7 @@
                 <p:ph idx="1"/>
                 <p:extLst>
                   <p:ext uri="{D42A27DB-BD31-4B8C-83A1-F6EECF244321}">
-                    <p14:modId xmlns:p14="http://schemas.microsoft.com/office/powerpoint/2010/main" val="1203504456"/>
+                    <p14:modId xmlns:p14="http://schemas.microsoft.com/office/powerpoint/2010/main" val="2995992197"/>
                   </p:ext>
                 </p:extLst>
               </p:nvPr>

</xml_diff>